<commit_message>
added all artworks on paper, ceramics and resorting sub sections
</commit_message>
<xml_diff>
--- a/images/on paper/logos creator.pptx
+++ b/images/on paper/logos creator.pptx
@@ -6,6 +6,7 @@
   </p:sldMasterIdLst>
   <p:sldIdLst>
     <p:sldId id="259" r:id="rId2"/>
+    <p:sldId id="260" r:id="rId3"/>
   </p:sldIdLst>
   <p:sldSz cx="12192000" cy="6858000"/>
   <p:notesSz cx="6858000" cy="9144000"/>
@@ -125,7 +126,7 @@
   <pc:docChgLst>
     <pc:chgData name="Lorenzo Taddei" userId="30bf616d265f9878" providerId="LiveId" clId="{6FD03176-F394-4DE9-9E07-BC8A4F6F06C0}"/>
     <pc:docChg chg="undo redo custSel addSld delSld modSld">
-      <pc:chgData name="Lorenzo Taddei" userId="30bf616d265f9878" providerId="LiveId" clId="{6FD03176-F394-4DE9-9E07-BC8A4F6F06C0}" dt="2025-09-27T09:32:43.250" v="1524" actId="2696"/>
+      <pc:chgData name="Lorenzo Taddei" userId="30bf616d265f9878" providerId="LiveId" clId="{6FD03176-F394-4DE9-9E07-BC8A4F6F06C0}" dt="2025-09-27T16:27:47.008" v="1558" actId="313"/>
       <pc:docMkLst>
         <pc:docMk/>
       </pc:docMkLst>
@@ -318,7 +319,7 @@
         </pc:sldMkLst>
       </pc:sldChg>
       <pc:sldChg chg="addSp delSp modSp new mod setBg">
-        <pc:chgData name="Lorenzo Taddei" userId="30bf616d265f9878" providerId="LiveId" clId="{6FD03176-F394-4DE9-9E07-BC8A4F6F06C0}" dt="2025-09-27T09:31:55.199" v="1523" actId="207"/>
+        <pc:chgData name="Lorenzo Taddei" userId="30bf616d265f9878" providerId="LiveId" clId="{6FD03176-F394-4DE9-9E07-BC8A4F6F06C0}" dt="2025-09-27T16:24:05.415" v="1533" actId="20577"/>
         <pc:sldMkLst>
           <pc:docMk/>
           <pc:sldMk cId="3354178094" sldId="259"/>
@@ -356,7 +357,7 @@
           </ac:spMkLst>
         </pc:spChg>
         <pc:spChg chg="add mod">
-          <ac:chgData name="Lorenzo Taddei" userId="30bf616d265f9878" providerId="LiveId" clId="{6FD03176-F394-4DE9-9E07-BC8A4F6F06C0}" dt="2025-09-27T09:27:58.285" v="1508" actId="1076"/>
+          <ac:chgData name="Lorenzo Taddei" userId="30bf616d265f9878" providerId="LiveId" clId="{6FD03176-F394-4DE9-9E07-BC8A4F6F06C0}" dt="2025-09-27T16:14:15.418" v="1530" actId="20577"/>
           <ac:spMkLst>
             <pc:docMk/>
             <pc:sldMk cId="3354178094" sldId="259"/>
@@ -364,7 +365,7 @@
           </ac:spMkLst>
         </pc:spChg>
         <pc:spChg chg="add mod">
-          <ac:chgData name="Lorenzo Taddei" userId="30bf616d265f9878" providerId="LiveId" clId="{6FD03176-F394-4DE9-9E07-BC8A4F6F06C0}" dt="2025-09-27T09:25:44.403" v="1446" actId="207"/>
+          <ac:chgData name="Lorenzo Taddei" userId="30bf616d265f9878" providerId="LiveId" clId="{6FD03176-F394-4DE9-9E07-BC8A4F6F06C0}" dt="2025-09-27T16:24:05.415" v="1533" actId="20577"/>
           <ac:spMkLst>
             <pc:docMk/>
             <pc:sldMk cId="3354178094" sldId="259"/>
@@ -385,6 +386,37 @@
             <pc:docMk/>
             <pc:sldMk cId="3354178094" sldId="259"/>
             <ac:spMk id="9" creationId="{3B6C51F0-028F-3DAE-C742-1028F8010DD5}"/>
+          </ac:spMkLst>
+        </pc:spChg>
+      </pc:sldChg>
+      <pc:sldChg chg="modSp add mod">
+        <pc:chgData name="Lorenzo Taddei" userId="30bf616d265f9878" providerId="LiveId" clId="{6FD03176-F394-4DE9-9E07-BC8A4F6F06C0}" dt="2025-09-27T16:27:47.008" v="1558" actId="313"/>
+        <pc:sldMkLst>
+          <pc:docMk/>
+          <pc:sldMk cId="1867763902" sldId="260"/>
+        </pc:sldMkLst>
+        <pc:spChg chg="mod">
+          <ac:chgData name="Lorenzo Taddei" userId="30bf616d265f9878" providerId="LiveId" clId="{6FD03176-F394-4DE9-9E07-BC8A4F6F06C0}" dt="2025-09-27T16:27:47.008" v="1558" actId="313"/>
+          <ac:spMkLst>
+            <pc:docMk/>
+            <pc:sldMk cId="1867763902" sldId="260"/>
+            <ac:spMk id="4" creationId="{4CE36089-89E3-E961-7EB6-3144A9A60B1E}"/>
+          </ac:spMkLst>
+        </pc:spChg>
+        <pc:spChg chg="mod">
+          <ac:chgData name="Lorenzo Taddei" userId="30bf616d265f9878" providerId="LiveId" clId="{6FD03176-F394-4DE9-9E07-BC8A4F6F06C0}" dt="2025-09-27T16:26:24.406" v="1555" actId="20577"/>
+          <ac:spMkLst>
+            <pc:docMk/>
+            <pc:sldMk cId="1867763902" sldId="260"/>
+            <ac:spMk id="7" creationId="{23EC75B3-83C9-FBEE-AA10-F89D59B8B953}"/>
+          </ac:spMkLst>
+        </pc:spChg>
+        <pc:spChg chg="mod">
+          <ac:chgData name="Lorenzo Taddei" userId="30bf616d265f9878" providerId="LiveId" clId="{6FD03176-F394-4DE9-9E07-BC8A4F6F06C0}" dt="2025-09-27T16:26:07.067" v="1553" actId="1076"/>
+          <ac:spMkLst>
+            <pc:docMk/>
+            <pc:sldMk cId="1867763902" sldId="260"/>
+            <ac:spMk id="8" creationId="{BFEB4827-7CA8-1973-B00C-B9388DA7CAE8}"/>
           </ac:spMkLst>
         </pc:spChg>
       </pc:sldChg>
@@ -4521,7 +4553,7 @@
                 <a:ea typeface="+mn-ea"/>
                 <a:cs typeface="+mn-cs"/>
               </a:rPr>
-              <a:t>Graffiti &amp; comic style</a:t>
+              <a:t>More</a:t>
             </a:r>
           </a:p>
         </p:txBody>
@@ -4603,7 +4635,7 @@
                 </a:solidFill>
                 <a:latin typeface="Bahnschrift SemiLight" panose="020B0502040204020203" pitchFamily="34" charset="0"/>
               </a:rPr>
-              <a:t>Charcoal and pencil</a:t>
+              <a:t>Charcoal</a:t>
             </a:r>
           </a:p>
         </p:txBody>
@@ -4832,6 +4864,575 @@
     <p:extLst>
       <p:ext uri="{BB962C8B-B14F-4D97-AF65-F5344CB8AC3E}">
         <p14:creationId xmlns:p14="http://schemas.microsoft.com/office/powerpoint/2010/main" val="3354178094"/>
+      </p:ext>
+    </p:extLst>
+  </p:cSld>
+  <p:clrMapOvr>
+    <a:masterClrMapping/>
+  </p:clrMapOvr>
+</p:sld>
+</file>
+
+<file path=ppt/slides/slide2.xml><?xml version="1.0" encoding="utf-8"?>
+<p:sld xmlns:a="http://schemas.openxmlformats.org/drawingml/2006/main" xmlns:r="http://schemas.openxmlformats.org/officeDocument/2006/relationships" xmlns:p="http://schemas.openxmlformats.org/presentationml/2006/main">
+  <p:cSld>
+    <p:bg>
+      <p:bgPr>
+        <a:solidFill>
+          <a:schemeClr val="bg2">
+            <a:lumMod val="20000"/>
+            <a:lumOff val="80000"/>
+          </a:schemeClr>
+        </a:solidFill>
+        <a:effectLst/>
+      </p:bgPr>
+    </p:bg>
+    <p:spTree>
+      <p:nvGrpSpPr>
+        <p:cNvPr id="1" name="">
+          <a:extLst>
+            <a:ext uri="{FF2B5EF4-FFF2-40B4-BE49-F238E27FC236}">
+              <a16:creationId xmlns:a16="http://schemas.microsoft.com/office/drawing/2014/main" id="{56B1B06B-008E-EE89-D896-784CCCC7695B}"/>
+            </a:ext>
+          </a:extLst>
+        </p:cNvPr>
+        <p:cNvGrpSpPr/>
+        <p:nvPr/>
+      </p:nvGrpSpPr>
+      <p:grpSpPr>
+        <a:xfrm>
+          <a:off x="0" y="0"/>
+          <a:ext cx="0" cy="0"/>
+          <a:chOff x="0" y="0"/>
+          <a:chExt cx="0" cy="0"/>
+        </a:xfrm>
+      </p:grpSpPr>
+      <p:sp>
+        <p:nvSpPr>
+          <p:cNvPr id="4" name="Rectangle: Rounded Corners 3">
+            <a:extLst>
+              <a:ext uri="{FF2B5EF4-FFF2-40B4-BE49-F238E27FC236}">
+                <a16:creationId xmlns:a16="http://schemas.microsoft.com/office/drawing/2014/main" id="{4CE36089-89E3-E961-7EB6-3144A9A60B1E}"/>
+              </a:ext>
+            </a:extLst>
+          </p:cNvPr>
+          <p:cNvSpPr/>
+          <p:nvPr/>
+        </p:nvSpPr>
+        <p:spPr>
+          <a:xfrm>
+            <a:off x="5730240" y="683261"/>
+            <a:ext cx="3779520" cy="718819"/>
+          </a:xfrm>
+          <a:prstGeom prst="roundRect">
+            <a:avLst/>
+          </a:prstGeom>
+          <a:gradFill flip="none" rotWithShape="1">
+            <a:gsLst>
+              <a:gs pos="0">
+                <a:schemeClr val="accent4">
+                  <a:lumMod val="67000"/>
+                </a:schemeClr>
+              </a:gs>
+              <a:gs pos="48000">
+                <a:schemeClr val="accent4">
+                  <a:lumMod val="97000"/>
+                  <a:lumOff val="3000"/>
+                </a:schemeClr>
+              </a:gs>
+              <a:gs pos="100000">
+                <a:schemeClr val="accent4">
+                  <a:lumMod val="60000"/>
+                  <a:lumOff val="40000"/>
+                </a:schemeClr>
+              </a:gs>
+            </a:gsLst>
+            <a:lin ang="16200000" scaled="1"/>
+            <a:tileRect/>
+          </a:gradFill>
+          <a:ln w="19050">
+            <a:solidFill>
+              <a:schemeClr val="tx2"/>
+            </a:solidFill>
+          </a:ln>
+        </p:spPr>
+        <p:style>
+          <a:lnRef idx="0">
+            <a:scrgbClr r="0" g="0" b="0"/>
+          </a:lnRef>
+          <a:fillRef idx="0">
+            <a:scrgbClr r="0" g="0" b="0"/>
+          </a:fillRef>
+          <a:effectRef idx="0">
+            <a:scrgbClr r="0" g="0" b="0"/>
+          </a:effectRef>
+          <a:fontRef idx="minor">
+            <a:schemeClr val="lt1"/>
+          </a:fontRef>
+        </p:style>
+        <p:txBody>
+          <a:bodyPr rtlCol="0" anchor="ctr"/>
+          <a:lstStyle/>
+          <a:p>
+            <a:pPr marL="0" marR="0" lvl="0" indent="0" algn="ctr" defTabSz="457200" rtl="0" eaLnBrk="1" fontAlgn="auto" latinLnBrk="0" hangingPunct="1">
+              <a:lnSpc>
+                <a:spcPct val="100000"/>
+              </a:lnSpc>
+              <a:spcBef>
+                <a:spcPts val="0"/>
+              </a:spcBef>
+              <a:spcAft>
+                <a:spcPts val="0"/>
+              </a:spcAft>
+              <a:buClrTx/>
+              <a:buSzTx/>
+              <a:buFontTx/>
+              <a:buNone/>
+              <a:tabLst/>
+              <a:defRPr/>
+            </a:pPr>
+            <a:r>
+              <a:rPr lang="en-US" sz="2400" dirty="0">
+                <a:solidFill>
+                  <a:srgbClr val="545454">
+                    <a:lumMod val="75000"/>
+                  </a:srgbClr>
+                </a:solidFill>
+                <a:latin typeface="Bahnschrift SemiLight" panose="020B0502040204020203" pitchFamily="34" charset="0"/>
+              </a:rPr>
+              <a:t>Wood working</a:t>
+            </a:r>
+            <a:endParaRPr kumimoji="0" lang="en-US" sz="2400" b="0" i="0" u="none" strike="noStrike" kern="1200" cap="none" spc="0" normalizeH="0" baseline="0" noProof="0" dirty="0">
+              <a:ln>
+                <a:noFill/>
+              </a:ln>
+              <a:solidFill>
+                <a:srgbClr val="545454">
+                  <a:lumMod val="75000"/>
+                </a:srgbClr>
+              </a:solidFill>
+              <a:effectLst/>
+              <a:uLnTx/>
+              <a:uFillTx/>
+              <a:latin typeface="Bahnschrift SemiLight" panose="020B0502040204020203" pitchFamily="34" charset="0"/>
+              <a:ea typeface="+mn-ea"/>
+              <a:cs typeface="+mn-cs"/>
+            </a:endParaRPr>
+          </a:p>
+        </p:txBody>
+      </p:sp>
+      <p:sp>
+        <p:nvSpPr>
+          <p:cNvPr id="6" name="Rectangle: Rounded Corners 5">
+            <a:extLst>
+              <a:ext uri="{FF2B5EF4-FFF2-40B4-BE49-F238E27FC236}">
+                <a16:creationId xmlns:a16="http://schemas.microsoft.com/office/drawing/2014/main" id="{B6B31129-E7FB-E787-68BC-CDF84282A48C}"/>
+              </a:ext>
+            </a:extLst>
+          </p:cNvPr>
+          <p:cNvSpPr/>
+          <p:nvPr/>
+        </p:nvSpPr>
+        <p:spPr>
+          <a:xfrm>
+            <a:off x="1371600" y="1866900"/>
+            <a:ext cx="3779520" cy="711200"/>
+          </a:xfrm>
+          <a:prstGeom prst="roundRect">
+            <a:avLst/>
+          </a:prstGeom>
+          <a:gradFill flip="none" rotWithShape="1">
+            <a:gsLst>
+              <a:gs pos="0">
+                <a:schemeClr val="accent3">
+                  <a:lumMod val="67000"/>
+                </a:schemeClr>
+              </a:gs>
+              <a:gs pos="48000">
+                <a:schemeClr val="accent3">
+                  <a:lumMod val="97000"/>
+                  <a:lumOff val="3000"/>
+                </a:schemeClr>
+              </a:gs>
+              <a:gs pos="100000">
+                <a:schemeClr val="accent3">
+                  <a:lumMod val="60000"/>
+                  <a:lumOff val="40000"/>
+                </a:schemeClr>
+              </a:gs>
+            </a:gsLst>
+            <a:lin ang="16200000" scaled="1"/>
+            <a:tileRect/>
+          </a:gradFill>
+          <a:ln w="19050">
+            <a:solidFill>
+              <a:schemeClr val="tx2"/>
+            </a:solidFill>
+          </a:ln>
+        </p:spPr>
+        <p:style>
+          <a:lnRef idx="0">
+            <a:scrgbClr r="0" g="0" b="0"/>
+          </a:lnRef>
+          <a:fillRef idx="0">
+            <a:scrgbClr r="0" g="0" b="0"/>
+          </a:fillRef>
+          <a:effectRef idx="0">
+            <a:scrgbClr r="0" g="0" b="0"/>
+          </a:effectRef>
+          <a:fontRef idx="minor">
+            <a:schemeClr val="lt1"/>
+          </a:fontRef>
+        </p:style>
+        <p:txBody>
+          <a:bodyPr rtlCol="0" anchor="ctr"/>
+          <a:lstStyle/>
+          <a:p>
+            <a:pPr marL="0" marR="0" lvl="0" indent="0" algn="ctr" defTabSz="457200" rtl="0" eaLnBrk="1" fontAlgn="auto" latinLnBrk="0" hangingPunct="1">
+              <a:lnSpc>
+                <a:spcPct val="100000"/>
+              </a:lnSpc>
+              <a:spcBef>
+                <a:spcPts val="0"/>
+              </a:spcBef>
+              <a:spcAft>
+                <a:spcPts val="0"/>
+              </a:spcAft>
+              <a:buClrTx/>
+              <a:buSzTx/>
+              <a:buFontTx/>
+              <a:buNone/>
+              <a:tabLst/>
+              <a:defRPr/>
+            </a:pPr>
+            <a:r>
+              <a:rPr kumimoji="0" lang="en-US" sz="2400" b="0" i="0" u="none" strike="noStrike" kern="1200" cap="none" spc="0" normalizeH="0" baseline="0" noProof="0" dirty="0">
+                <a:ln>
+                  <a:noFill/>
+                </a:ln>
+                <a:solidFill>
+                  <a:srgbClr val="545454">
+                    <a:lumMod val="75000"/>
+                  </a:srgbClr>
+                </a:solidFill>
+                <a:effectLst/>
+                <a:uLnTx/>
+                <a:uFillTx/>
+                <a:latin typeface="Bahnschrift SemiLight" panose="020B0502040204020203" pitchFamily="34" charset="0"/>
+                <a:ea typeface="+mn-ea"/>
+                <a:cs typeface="+mn-cs"/>
+              </a:rPr>
+              <a:t>More</a:t>
+            </a:r>
+          </a:p>
+        </p:txBody>
+      </p:sp>
+      <p:sp>
+        <p:nvSpPr>
+          <p:cNvPr id="7" name="Rectangle: Rounded Corners 6">
+            <a:extLst>
+              <a:ext uri="{FF2B5EF4-FFF2-40B4-BE49-F238E27FC236}">
+                <a16:creationId xmlns:a16="http://schemas.microsoft.com/office/drawing/2014/main" id="{23EC75B3-83C9-FBEE-AA10-F89D59B8B953}"/>
+              </a:ext>
+            </a:extLst>
+          </p:cNvPr>
+          <p:cNvSpPr/>
+          <p:nvPr/>
+        </p:nvSpPr>
+        <p:spPr>
+          <a:xfrm>
+            <a:off x="1371600" y="690880"/>
+            <a:ext cx="3779520" cy="711200"/>
+          </a:xfrm>
+          <a:prstGeom prst="roundRect">
+            <a:avLst/>
+          </a:prstGeom>
+          <a:gradFill flip="none" rotWithShape="1">
+            <a:gsLst>
+              <a:gs pos="0">
+                <a:schemeClr val="accent2">
+                  <a:lumMod val="67000"/>
+                </a:schemeClr>
+              </a:gs>
+              <a:gs pos="48000">
+                <a:schemeClr val="accent2">
+                  <a:lumMod val="97000"/>
+                  <a:lumOff val="3000"/>
+                </a:schemeClr>
+              </a:gs>
+              <a:gs pos="100000">
+                <a:schemeClr val="accent2">
+                  <a:lumMod val="60000"/>
+                  <a:lumOff val="40000"/>
+                </a:schemeClr>
+              </a:gs>
+            </a:gsLst>
+            <a:lin ang="16200000" scaled="1"/>
+            <a:tileRect/>
+          </a:gradFill>
+          <a:ln w="19050">
+            <a:solidFill>
+              <a:schemeClr val="tx2"/>
+            </a:solidFill>
+          </a:ln>
+        </p:spPr>
+        <p:style>
+          <a:lnRef idx="0">
+            <a:scrgbClr r="0" g="0" b="0"/>
+          </a:lnRef>
+          <a:fillRef idx="0">
+            <a:scrgbClr r="0" g="0" b="0"/>
+          </a:fillRef>
+          <a:effectRef idx="0">
+            <a:scrgbClr r="0" g="0" b="0"/>
+          </a:effectRef>
+          <a:fontRef idx="minor">
+            <a:schemeClr val="lt1"/>
+          </a:fontRef>
+        </p:style>
+        <p:txBody>
+          <a:bodyPr rtlCol="0" anchor="ctr"/>
+          <a:lstStyle/>
+          <a:p>
+            <a:pPr algn="ctr"/>
+            <a:r>
+              <a:rPr lang="en-US" sz="2400" dirty="0">
+                <a:solidFill>
+                  <a:schemeClr val="tx2">
+                    <a:lumMod val="75000"/>
+                  </a:schemeClr>
+                </a:solidFill>
+                <a:latin typeface="Bahnschrift SemiLight" panose="020B0502040204020203" pitchFamily="34" charset="0"/>
+              </a:rPr>
+              <a:t>Ceramics</a:t>
+            </a:r>
+          </a:p>
+        </p:txBody>
+      </p:sp>
+      <p:sp>
+        <p:nvSpPr>
+          <p:cNvPr id="8" name="Rectangle: Rounded Corners 7">
+            <a:extLst>
+              <a:ext uri="{FF2B5EF4-FFF2-40B4-BE49-F238E27FC236}">
+                <a16:creationId xmlns:a16="http://schemas.microsoft.com/office/drawing/2014/main" id="{BFEB4827-7CA8-1973-B00C-B9388DA7CAE8}"/>
+              </a:ext>
+            </a:extLst>
+          </p:cNvPr>
+          <p:cNvSpPr/>
+          <p:nvPr/>
+        </p:nvSpPr>
+        <p:spPr>
+          <a:xfrm>
+            <a:off x="5730240" y="1866900"/>
+            <a:ext cx="3779520" cy="711200"/>
+          </a:xfrm>
+          <a:prstGeom prst="roundRect">
+            <a:avLst/>
+          </a:prstGeom>
+          <a:gradFill flip="none" rotWithShape="1">
+            <a:gsLst>
+              <a:gs pos="0">
+                <a:srgbClr val="1E929E"/>
+              </a:gs>
+              <a:gs pos="48000">
+                <a:srgbClr val="66D4CF"/>
+              </a:gs>
+              <a:gs pos="100000">
+                <a:srgbClr val="87E0E9"/>
+              </a:gs>
+            </a:gsLst>
+            <a:lin ang="16200000" scaled="1"/>
+            <a:tileRect/>
+          </a:gradFill>
+          <a:ln w="19050">
+            <a:solidFill>
+              <a:schemeClr val="tx2"/>
+            </a:solidFill>
+          </a:ln>
+        </p:spPr>
+        <p:style>
+          <a:lnRef idx="0">
+            <a:scrgbClr r="0" g="0" b="0"/>
+          </a:lnRef>
+          <a:fillRef idx="0">
+            <a:scrgbClr r="0" g="0" b="0"/>
+          </a:fillRef>
+          <a:effectRef idx="0">
+            <a:scrgbClr r="0" g="0" b="0"/>
+          </a:effectRef>
+          <a:fontRef idx="minor">
+            <a:schemeClr val="lt1"/>
+          </a:fontRef>
+        </p:style>
+        <p:txBody>
+          <a:bodyPr rtlCol="0" anchor="ctr"/>
+          <a:lstStyle/>
+          <a:p>
+            <a:pPr marL="0" marR="0" lvl="0" indent="0" algn="ctr" defTabSz="457200" rtl="0" eaLnBrk="1" fontAlgn="auto" latinLnBrk="0" hangingPunct="1">
+              <a:lnSpc>
+                <a:spcPct val="100000"/>
+              </a:lnSpc>
+              <a:spcBef>
+                <a:spcPts val="0"/>
+              </a:spcBef>
+              <a:spcAft>
+                <a:spcPts val="0"/>
+              </a:spcAft>
+              <a:buClrTx/>
+              <a:buSzTx/>
+              <a:buFontTx/>
+              <a:buNone/>
+              <a:tabLst/>
+              <a:defRPr/>
+            </a:pPr>
+            <a:r>
+              <a:rPr kumimoji="0" lang="en-US" sz="2400" b="0" i="0" u="none" strike="noStrike" kern="1200" cap="none" spc="0" normalizeH="0" baseline="0" noProof="0" dirty="0">
+                <a:ln>
+                  <a:noFill/>
+                </a:ln>
+                <a:solidFill>
+                  <a:srgbClr val="545454">
+                    <a:lumMod val="75000"/>
+                  </a:srgbClr>
+                </a:solidFill>
+                <a:effectLst/>
+                <a:uLnTx/>
+                <a:uFillTx/>
+                <a:latin typeface="Bahnschrift SemiLight" panose="020B0502040204020203" pitchFamily="34" charset="0"/>
+                <a:ea typeface="+mn-ea"/>
+                <a:cs typeface="+mn-cs"/>
+              </a:rPr>
+              <a:t>Calligraphy</a:t>
+            </a:r>
+          </a:p>
+        </p:txBody>
+      </p:sp>
+      <p:sp>
+        <p:nvSpPr>
+          <p:cNvPr id="9" name="Rectangle: Rounded Corners 8">
+            <a:extLst>
+              <a:ext uri="{FF2B5EF4-FFF2-40B4-BE49-F238E27FC236}">
+                <a16:creationId xmlns:a16="http://schemas.microsoft.com/office/drawing/2014/main" id="{D919ACE5-13AB-C4BD-D451-005C4BC84A5B}"/>
+              </a:ext>
+            </a:extLst>
+          </p:cNvPr>
+          <p:cNvSpPr/>
+          <p:nvPr/>
+        </p:nvSpPr>
+        <p:spPr>
+          <a:xfrm>
+            <a:off x="1371600" y="3042920"/>
+            <a:ext cx="3779520" cy="711200"/>
+          </a:xfrm>
+          <a:prstGeom prst="roundRect">
+            <a:avLst/>
+          </a:prstGeom>
+          <a:gradFill flip="none" rotWithShape="1">
+            <a:gsLst>
+              <a:gs pos="0">
+                <a:schemeClr val="accent5">
+                  <a:lumMod val="67000"/>
+                </a:schemeClr>
+              </a:gs>
+              <a:gs pos="48000">
+                <a:schemeClr val="accent5">
+                  <a:lumMod val="97000"/>
+                  <a:lumOff val="3000"/>
+                </a:schemeClr>
+              </a:gs>
+              <a:gs pos="100000">
+                <a:schemeClr val="accent5">
+                  <a:lumMod val="60000"/>
+                  <a:lumOff val="40000"/>
+                </a:schemeClr>
+              </a:gs>
+            </a:gsLst>
+            <a:lin ang="16200000" scaled="1"/>
+            <a:tileRect/>
+          </a:gradFill>
+          <a:ln w="19050">
+            <a:solidFill>
+              <a:schemeClr val="tx2"/>
+            </a:solidFill>
+          </a:ln>
+        </p:spPr>
+        <p:style>
+          <a:lnRef idx="0">
+            <a:scrgbClr r="0" g="0" b="0"/>
+          </a:lnRef>
+          <a:fillRef idx="0">
+            <a:scrgbClr r="0" g="0" b="0"/>
+          </a:fillRef>
+          <a:effectRef idx="0">
+            <a:scrgbClr r="0" g="0" b="0"/>
+          </a:effectRef>
+          <a:fontRef idx="minor">
+            <a:schemeClr val="lt1"/>
+          </a:fontRef>
+        </p:style>
+        <p:txBody>
+          <a:bodyPr rtlCol="0" anchor="ctr"/>
+          <a:lstStyle/>
+          <a:p>
+            <a:pPr marL="0" marR="0" lvl="0" indent="0" algn="ctr" defTabSz="457200" rtl="0" eaLnBrk="1" fontAlgn="auto" latinLnBrk="0" hangingPunct="1">
+              <a:lnSpc>
+                <a:spcPct val="100000"/>
+              </a:lnSpc>
+              <a:spcBef>
+                <a:spcPts val="0"/>
+              </a:spcBef>
+              <a:spcAft>
+                <a:spcPts val="0"/>
+              </a:spcAft>
+              <a:buClrTx/>
+              <a:buSzTx/>
+              <a:buFontTx/>
+              <a:buNone/>
+              <a:tabLst/>
+              <a:defRPr/>
+            </a:pPr>
+            <a:r>
+              <a:rPr kumimoji="0" lang="en-US" sz="2400" b="0" i="0" u="none" strike="noStrike" kern="1200" cap="none" spc="0" normalizeH="0" baseline="0" noProof="0">
+                <a:ln>
+                  <a:noFill/>
+                </a:ln>
+                <a:solidFill>
+                  <a:srgbClr val="545454">
+                    <a:lumMod val="75000"/>
+                  </a:srgbClr>
+                </a:solidFill>
+                <a:effectLst/>
+                <a:uLnTx/>
+                <a:uFillTx/>
+                <a:latin typeface="Bahnschrift SemiLight" panose="020B0502040204020203" pitchFamily="34" charset="0"/>
+                <a:ea typeface="+mn-ea"/>
+                <a:cs typeface="+mn-cs"/>
+              </a:rPr>
+              <a:t>Charcoal and pencil</a:t>
+            </a:r>
+            <a:endParaRPr kumimoji="0" lang="en-US" sz="2400" b="0" i="0" u="none" strike="noStrike" kern="1200" cap="none" spc="0" normalizeH="0" baseline="0" noProof="0" dirty="0">
+              <a:ln>
+                <a:noFill/>
+              </a:ln>
+              <a:solidFill>
+                <a:srgbClr val="545454">
+                  <a:lumMod val="75000"/>
+                </a:srgbClr>
+              </a:solidFill>
+              <a:effectLst/>
+              <a:uLnTx/>
+              <a:uFillTx/>
+              <a:latin typeface="Bahnschrift SemiLight" panose="020B0502040204020203" pitchFamily="34" charset="0"/>
+              <a:ea typeface="+mn-ea"/>
+              <a:cs typeface="+mn-cs"/>
+            </a:endParaRPr>
+          </a:p>
+        </p:txBody>
+      </p:sp>
+    </p:spTree>
+    <p:extLst>
+      <p:ext uri="{BB962C8B-B14F-4D97-AF65-F5344CB8AC3E}">
+        <p14:creationId xmlns:p14="http://schemas.microsoft.com/office/powerpoint/2010/main" val="1867763902"/>
       </p:ext>
     </p:extLst>
   </p:cSld>

</xml_diff>

<commit_message>
adding more drawings, adjusting modal boxes
</commit_message>
<xml_diff>
--- a/images/on paper/logos creator.pptx
+++ b/images/on paper/logos creator.pptx
@@ -126,7 +126,7 @@
   <pc:docChgLst>
     <pc:chgData name="Lorenzo Taddei" userId="30bf616d265f9878" providerId="LiveId" clId="{6FD03176-F394-4DE9-9E07-BC8A4F6F06C0}"/>
     <pc:docChg chg="undo redo custSel addSld delSld modSld">
-      <pc:chgData name="Lorenzo Taddei" userId="30bf616d265f9878" providerId="LiveId" clId="{6FD03176-F394-4DE9-9E07-BC8A4F6F06C0}" dt="2025-09-27T16:27:47.008" v="1558" actId="313"/>
+      <pc:chgData name="Lorenzo Taddei" userId="30bf616d265f9878" providerId="LiveId" clId="{6FD03176-F394-4DE9-9E07-BC8A4F6F06C0}" dt="2025-09-28T09:25:47.113" v="1566" actId="20577"/>
       <pc:docMkLst>
         <pc:docMk/>
       </pc:docMkLst>
@@ -136,30 +136,6 @@
           <pc:docMk/>
           <pc:sldMk cId="3128625159" sldId="256"/>
         </pc:sldMkLst>
-        <pc:spChg chg="mod">
-          <ac:chgData name="Lorenzo Taddei" userId="30bf616d265f9878" providerId="LiveId" clId="{6FD03176-F394-4DE9-9E07-BC8A4F6F06C0}" dt="2025-09-26T16:43:13.681" v="7" actId="1076"/>
-          <ac:spMkLst>
-            <pc:docMk/>
-            <pc:sldMk cId="3128625159" sldId="256"/>
-            <ac:spMk id="2" creationId="{5482E93A-290F-B9A2-F7D2-1E6CC33FE04A}"/>
-          </ac:spMkLst>
-        </pc:spChg>
-        <pc:spChg chg="del mod">
-          <ac:chgData name="Lorenzo Taddei" userId="30bf616d265f9878" providerId="LiveId" clId="{6FD03176-F394-4DE9-9E07-BC8A4F6F06C0}" dt="2025-09-26T16:43:19.022" v="8" actId="478"/>
-          <ac:spMkLst>
-            <pc:docMk/>
-            <pc:sldMk cId="3128625159" sldId="256"/>
-            <ac:spMk id="3" creationId="{30DAED56-8D84-6CE0-5E9D-727879AE6636}"/>
-          </ac:spMkLst>
-        </pc:spChg>
-        <pc:picChg chg="add mod">
-          <ac:chgData name="Lorenzo Taddei" userId="30bf616d265f9878" providerId="LiveId" clId="{6FD03176-F394-4DE9-9E07-BC8A4F6F06C0}" dt="2025-09-26T16:43:23.545" v="10" actId="1076"/>
-          <ac:picMkLst>
-            <pc:docMk/>
-            <pc:sldMk cId="3128625159" sldId="256"/>
-            <ac:picMk id="1026" creationId="{67E8A050-F584-73FB-AF23-DD9CBFB30627}"/>
-          </ac:picMkLst>
-        </pc:picChg>
       </pc:sldChg>
       <pc:sldChg chg="addSp delSp modSp new del mod">
         <pc:chgData name="Lorenzo Taddei" userId="30bf616d265f9878" providerId="LiveId" clId="{6FD03176-F394-4DE9-9E07-BC8A4F6F06C0}" dt="2025-09-26T17:30:34.657" v="576" actId="47"/>
@@ -167,54 +143,6 @@
           <pc:docMk/>
           <pc:sldMk cId="87234602" sldId="257"/>
         </pc:sldMkLst>
-        <pc:spChg chg="mod ord">
-          <ac:chgData name="Lorenzo Taddei" userId="30bf616d265f9878" providerId="LiveId" clId="{6FD03176-F394-4DE9-9E07-BC8A4F6F06C0}" dt="2025-09-26T16:49:58.164" v="106" actId="1076"/>
-          <ac:spMkLst>
-            <pc:docMk/>
-            <pc:sldMk cId="87234602" sldId="257"/>
-            <ac:spMk id="2" creationId="{D98E16F0-B944-2E98-A9DC-00245D56D225}"/>
-          </ac:spMkLst>
-        </pc:spChg>
-        <pc:spChg chg="del">
-          <ac:chgData name="Lorenzo Taddei" userId="30bf616d265f9878" providerId="LiveId" clId="{6FD03176-F394-4DE9-9E07-BC8A4F6F06C0}" dt="2025-09-26T16:44:04.839" v="25" actId="478"/>
-          <ac:spMkLst>
-            <pc:docMk/>
-            <pc:sldMk cId="87234602" sldId="257"/>
-            <ac:spMk id="3" creationId="{1D0A2C46-A838-6534-EE76-8F22A7018A54}"/>
-          </ac:spMkLst>
-        </pc:spChg>
-        <pc:spChg chg="add del mod ord">
-          <ac:chgData name="Lorenzo Taddei" userId="30bf616d265f9878" providerId="LiveId" clId="{6FD03176-F394-4DE9-9E07-BC8A4F6F06C0}" dt="2025-09-26T16:50:08.472" v="134" actId="207"/>
-          <ac:spMkLst>
-            <pc:docMk/>
-            <pc:sldMk cId="87234602" sldId="257"/>
-            <ac:spMk id="5" creationId="{D010B1FD-9A57-CBE2-C7B4-90C1F6DBACBA}"/>
-          </ac:spMkLst>
-        </pc:spChg>
-        <pc:spChg chg="add del">
-          <ac:chgData name="Lorenzo Taddei" userId="30bf616d265f9878" providerId="LiveId" clId="{6FD03176-F394-4DE9-9E07-BC8A4F6F06C0}" dt="2025-09-26T16:48:28.799" v="93" actId="11529"/>
-          <ac:spMkLst>
-            <pc:docMk/>
-            <pc:sldMk cId="87234602" sldId="257"/>
-            <ac:spMk id="6" creationId="{F8AB4E5E-3380-FAAB-84AA-6664946E5A25}"/>
-          </ac:spMkLst>
-        </pc:spChg>
-        <pc:spChg chg="add del mod">
-          <ac:chgData name="Lorenzo Taddei" userId="30bf616d265f9878" providerId="LiveId" clId="{6FD03176-F394-4DE9-9E07-BC8A4F6F06C0}" dt="2025-09-26T16:49:45.532" v="105" actId="478"/>
-          <ac:spMkLst>
-            <pc:docMk/>
-            <pc:sldMk cId="87234602" sldId="257"/>
-            <ac:spMk id="7" creationId="{D364CBD3-E369-AF91-613E-3A11B5B43917}"/>
-          </ac:spMkLst>
-        </pc:spChg>
-        <pc:picChg chg="add mod">
-          <ac:chgData name="Lorenzo Taddei" userId="30bf616d265f9878" providerId="LiveId" clId="{6FD03176-F394-4DE9-9E07-BC8A4F6F06C0}" dt="2025-09-26T16:46:55.432" v="86" actId="732"/>
-          <ac:picMkLst>
-            <pc:docMk/>
-            <pc:sldMk cId="87234602" sldId="257"/>
-            <ac:picMk id="4" creationId="{7C271881-5D2E-09F0-D943-9953CE7CB892}"/>
-          </ac:picMkLst>
-        </pc:picChg>
       </pc:sldChg>
       <pc:sldChg chg="addSp delSp modSp add del mod setBg">
         <pc:chgData name="Lorenzo Taddei" userId="30bf616d265f9878" providerId="LiveId" clId="{6FD03176-F394-4DE9-9E07-BC8A4F6F06C0}" dt="2025-09-27T09:32:43.250" v="1524" actId="2696"/>
@@ -231,14 +159,6 @@
           </ac:spMkLst>
         </pc:spChg>
         <pc:spChg chg="add mod">
-          <ac:chgData name="Lorenzo Taddei" userId="30bf616d265f9878" providerId="LiveId" clId="{6FD03176-F394-4DE9-9E07-BC8A4F6F06C0}" dt="2025-09-26T17:28:16.267" v="561" actId="14100"/>
-          <ac:spMkLst>
-            <pc:docMk/>
-            <pc:sldMk cId="1414499774" sldId="258"/>
-            <ac:spMk id="3" creationId="{2049DF0D-BE30-68FC-2AB3-DD5F08CF36C3}"/>
-          </ac:spMkLst>
-        </pc:spChg>
-        <pc:spChg chg="add mod">
           <ac:chgData name="Lorenzo Taddei" userId="30bf616d265f9878" providerId="LiveId" clId="{6FD03176-F394-4DE9-9E07-BC8A4F6F06C0}" dt="2025-09-27T09:00:21.855" v="673" actId="1076"/>
           <ac:spMkLst>
             <pc:docMk/>
@@ -252,30 +172,6 @@
             <pc:docMk/>
             <pc:sldMk cId="1414499774" sldId="258"/>
             <ac:spMk id="5" creationId="{ABD94CCA-813C-9D63-F000-655479DFDC6E}"/>
-          </ac:spMkLst>
-        </pc:spChg>
-        <pc:spChg chg="del mod">
-          <ac:chgData name="Lorenzo Taddei" userId="30bf616d265f9878" providerId="LiveId" clId="{6FD03176-F394-4DE9-9E07-BC8A4F6F06C0}" dt="2025-09-26T16:58:17.886" v="230" actId="478"/>
-          <ac:spMkLst>
-            <pc:docMk/>
-            <pc:sldMk cId="1414499774" sldId="258"/>
-            <ac:spMk id="5" creationId="{FE468607-A7C5-A8BD-6016-CFCB44CB57BD}"/>
-          </ac:spMkLst>
-        </pc:spChg>
-        <pc:spChg chg="add mod">
-          <ac:chgData name="Lorenzo Taddei" userId="30bf616d265f9878" providerId="LiveId" clId="{6FD03176-F394-4DE9-9E07-BC8A4F6F06C0}" dt="2025-09-26T17:30:02.886" v="575" actId="122"/>
-          <ac:spMkLst>
-            <pc:docMk/>
-            <pc:sldMk cId="1414499774" sldId="258"/>
-            <ac:spMk id="6" creationId="{870C8B4A-2F24-E1C0-4FB2-22C26718E0B8}"/>
-          </ac:spMkLst>
-        </pc:spChg>
-        <pc:spChg chg="add del mod">
-          <ac:chgData name="Lorenzo Taddei" userId="30bf616d265f9878" providerId="LiveId" clId="{6FD03176-F394-4DE9-9E07-BC8A4F6F06C0}" dt="2025-09-26T17:00:30.263" v="364" actId="478"/>
-          <ac:spMkLst>
-            <pc:docMk/>
-            <pc:sldMk cId="1414499774" sldId="258"/>
-            <ac:spMk id="7" creationId="{4432556D-11C6-6A45-3AEB-EDE2CA82E26F}"/>
           </ac:spMkLst>
         </pc:spChg>
         <pc:spChg chg="add mod">
@@ -302,14 +198,6 @@
             <ac:spMk id="9" creationId="{343B04B2-4F2C-4FCC-4489-213EE5FE6EF9}"/>
           </ac:spMkLst>
         </pc:spChg>
-        <pc:picChg chg="del">
-          <ac:chgData name="Lorenzo Taddei" userId="30bf616d265f9878" providerId="LiveId" clId="{6FD03176-F394-4DE9-9E07-BC8A4F6F06C0}" dt="2025-09-26T16:54:54.649" v="137" actId="478"/>
-          <ac:picMkLst>
-            <pc:docMk/>
-            <pc:sldMk cId="1414499774" sldId="258"/>
-            <ac:picMk id="4" creationId="{12F152E1-E6DE-88F7-B0A2-67D61EB94053}"/>
-          </ac:picMkLst>
-        </pc:picChg>
       </pc:sldChg>
       <pc:sldChg chg="new del">
         <pc:chgData name="Lorenzo Taddei" userId="30bf616d265f9878" providerId="LiveId" clId="{6FD03176-F394-4DE9-9E07-BC8A4F6F06C0}" dt="2025-09-27T09:17:42.789" v="1324" actId="47"/>
@@ -390,13 +278,13 @@
         </pc:spChg>
       </pc:sldChg>
       <pc:sldChg chg="modSp add mod">
-        <pc:chgData name="Lorenzo Taddei" userId="30bf616d265f9878" providerId="LiveId" clId="{6FD03176-F394-4DE9-9E07-BC8A4F6F06C0}" dt="2025-09-27T16:27:47.008" v="1558" actId="313"/>
+        <pc:chgData name="Lorenzo Taddei" userId="30bf616d265f9878" providerId="LiveId" clId="{6FD03176-F394-4DE9-9E07-BC8A4F6F06C0}" dt="2025-09-28T09:25:47.113" v="1566" actId="20577"/>
         <pc:sldMkLst>
           <pc:docMk/>
           <pc:sldMk cId="1867763902" sldId="260"/>
         </pc:sldMkLst>
         <pc:spChg chg="mod">
-          <ac:chgData name="Lorenzo Taddei" userId="30bf616d265f9878" providerId="LiveId" clId="{6FD03176-F394-4DE9-9E07-BC8A4F6F06C0}" dt="2025-09-27T16:27:47.008" v="1558" actId="313"/>
+          <ac:chgData name="Lorenzo Taddei" userId="30bf616d265f9878" providerId="LiveId" clId="{6FD03176-F394-4DE9-9E07-BC8A4F6F06C0}" dt="2025-09-28T09:25:47.113" v="1566" actId="20577"/>
           <ac:spMkLst>
             <pc:docMk/>
             <pc:sldMk cId="1867763902" sldId="260"/>
@@ -828,7 +716,7 @@
           <a:p>
             <a:fld id="{39598B85-B088-4DCF-AC6D-F6BFD5953725}" type="datetimeFigureOut">
               <a:rPr lang="en-US" smtClean="0"/>
-              <a:t>9/27/2025</a:t>
+              <a:t>9/28/2025</a:t>
             </a:fld>
             <a:endParaRPr lang="en-US"/>
           </a:p>
@@ -1007,7 +895,7 @@
           <a:p>
             <a:fld id="{39598B85-B088-4DCF-AC6D-F6BFD5953725}" type="datetimeFigureOut">
               <a:rPr lang="en-US" smtClean="0"/>
-              <a:t>9/27/2025</a:t>
+              <a:t>9/28/2025</a:t>
             </a:fld>
             <a:endParaRPr lang="en-US"/>
           </a:p>
@@ -1187,7 +1075,7 @@
           <a:p>
             <a:fld id="{39598B85-B088-4DCF-AC6D-F6BFD5953725}" type="datetimeFigureOut">
               <a:rPr lang="en-US" smtClean="0"/>
-              <a:t>9/27/2025</a:t>
+              <a:t>9/28/2025</a:t>
             </a:fld>
             <a:endParaRPr lang="en-US"/>
           </a:p>
@@ -1357,7 +1245,7 @@
           <a:p>
             <a:fld id="{39598B85-B088-4DCF-AC6D-F6BFD5953725}" type="datetimeFigureOut">
               <a:rPr lang="en-US" smtClean="0"/>
-              <a:t>9/27/2025</a:t>
+              <a:t>9/28/2025</a:t>
             </a:fld>
             <a:endParaRPr lang="en-US"/>
           </a:p>
@@ -1670,7 +1558,7 @@
           <a:p>
             <a:fld id="{39598B85-B088-4DCF-AC6D-F6BFD5953725}" type="datetimeFigureOut">
               <a:rPr lang="en-US" smtClean="0"/>
-              <a:t>9/27/2025</a:t>
+              <a:t>9/28/2025</a:t>
             </a:fld>
             <a:endParaRPr lang="en-US"/>
           </a:p>
@@ -2056,7 +1944,7 @@
           <a:p>
             <a:fld id="{39598B85-B088-4DCF-AC6D-F6BFD5953725}" type="datetimeFigureOut">
               <a:rPr lang="en-US" smtClean="0"/>
-              <a:t>9/27/2025</a:t>
+              <a:t>9/28/2025</a:t>
             </a:fld>
             <a:endParaRPr lang="en-US"/>
           </a:p>
@@ -2490,7 +2378,7 @@
           <a:p>
             <a:fld id="{39598B85-B088-4DCF-AC6D-F6BFD5953725}" type="datetimeFigureOut">
               <a:rPr lang="en-US" smtClean="0"/>
-              <a:t>9/27/2025</a:t>
+              <a:t>9/28/2025</a:t>
             </a:fld>
             <a:endParaRPr lang="en-US"/>
           </a:p>
@@ -2608,7 +2496,7 @@
           <a:p>
             <a:fld id="{39598B85-B088-4DCF-AC6D-F6BFD5953725}" type="datetimeFigureOut">
               <a:rPr lang="en-US" smtClean="0"/>
-              <a:t>9/27/2025</a:t>
+              <a:t>9/28/2025</a:t>
             </a:fld>
             <a:endParaRPr lang="en-US"/>
           </a:p>
@@ -2703,7 +2591,7 @@
           <a:p>
             <a:fld id="{39598B85-B088-4DCF-AC6D-F6BFD5953725}" type="datetimeFigureOut">
               <a:rPr lang="en-US" smtClean="0"/>
-              <a:t>9/27/2025</a:t>
+              <a:t>9/28/2025</a:t>
             </a:fld>
             <a:endParaRPr lang="en-US"/>
           </a:p>
@@ -3053,7 +2941,7 @@
           <a:p>
             <a:fld id="{39598B85-B088-4DCF-AC6D-F6BFD5953725}" type="datetimeFigureOut">
               <a:rPr lang="en-US" smtClean="0"/>
-              <a:t>9/27/2025</a:t>
+              <a:t>9/28/2025</a:t>
             </a:fld>
             <a:endParaRPr lang="en-US"/>
           </a:p>
@@ -3478,7 +3366,7 @@
           <a:p>
             <a:fld id="{39598B85-B088-4DCF-AC6D-F6BFD5953725}" type="datetimeFigureOut">
               <a:rPr lang="en-US" smtClean="0"/>
-              <a:t>9/27/2025</a:t>
+              <a:t>9/28/2025</a:t>
             </a:fld>
             <a:endParaRPr lang="en-US"/>
           </a:p>
@@ -3759,7 +3647,7 @@
           <a:p>
             <a:fld id="{39598B85-B088-4DCF-AC6D-F6BFD5953725}" type="datetimeFigureOut">
               <a:rPr lang="en-US" smtClean="0"/>
-              <a:t>9/27/2025</a:t>
+              <a:t>9/28/2025</a:t>
             </a:fld>
             <a:endParaRPr lang="en-US"/>
           </a:p>
@@ -5000,7 +4888,7 @@
                 </a:solidFill>
                 <a:latin typeface="Bahnschrift SemiLight" panose="020B0502040204020203" pitchFamily="34" charset="0"/>
               </a:rPr>
-              <a:t>Wood working</a:t>
+              <a:t>Ceramics</a:t>
             </a:r>
             <a:endParaRPr kumimoji="0" lang="en-US" sz="2400" b="0" i="0" u="none" strike="noStrike" kern="1200" cap="none" spc="0" normalizeH="0" baseline="0" noProof="0" dirty="0">
               <a:ln>

</xml_diff>

<commit_message>
rearrange sections, polished materials in side interests section, languages higher up
</commit_message>
<xml_diff>
--- a/images/on paper/logos creator.pptx
+++ b/images/on paper/logos creator.pptx
@@ -116,7 +116,7 @@
 <file path=ppt/revisionInfo.xml><?xml version="1.0" encoding="utf-8"?>
 <p1510:revInfo xmlns:a="http://schemas.openxmlformats.org/drawingml/2006/main" xmlns:r="http://schemas.openxmlformats.org/officeDocument/2006/relationships" xmlns:p1510="http://schemas.microsoft.com/office/powerpoint/2015/10/main">
   <p1510:revLst>
-    <p1510:client id="{414D2E25-DAF7-4A58-BD90-BE4007EBAADB}" v="67" dt="2025-09-27T09:26:05.286"/>
+    <p1510:client id="{EA1F40C3-A640-4FF9-A163-49B01836B37B}" v="1" dt="2026-03-17T16:47:30.702"/>
   </p1510:revLst>
 </p1510:revInfo>
 </file>
@@ -126,185 +126,30 @@
   <pc:docChgLst>
     <pc:chgData name="Lorenzo Taddei" userId="30bf616d265f9878" providerId="LiveId" clId="{6FD03176-F394-4DE9-9E07-BC8A4F6F06C0}"/>
     <pc:docChg chg="undo redo custSel addSld delSld modSld">
-      <pc:chgData name="Lorenzo Taddei" userId="30bf616d265f9878" providerId="LiveId" clId="{6FD03176-F394-4DE9-9E07-BC8A4F6F06C0}" dt="2025-09-28T09:25:47.113" v="1566" actId="20577"/>
+      <pc:chgData name="Lorenzo Taddei" userId="30bf616d265f9878" providerId="LiveId" clId="{6FD03176-F394-4DE9-9E07-BC8A4F6F06C0}" dt="2026-03-17T20:38:16.671" v="1589" actId="20577"/>
       <pc:docMkLst>
         <pc:docMk/>
       </pc:docMkLst>
-      <pc:sldChg chg="addSp delSp modSp new del mod">
-        <pc:chgData name="Lorenzo Taddei" userId="30bf616d265f9878" providerId="LiveId" clId="{6FD03176-F394-4DE9-9E07-BC8A4F6F06C0}" dt="2025-09-26T17:30:35.967" v="577" actId="47"/>
-        <pc:sldMkLst>
-          <pc:docMk/>
-          <pc:sldMk cId="3128625159" sldId="256"/>
-        </pc:sldMkLst>
-      </pc:sldChg>
-      <pc:sldChg chg="addSp delSp modSp new del mod">
-        <pc:chgData name="Lorenzo Taddei" userId="30bf616d265f9878" providerId="LiveId" clId="{6FD03176-F394-4DE9-9E07-BC8A4F6F06C0}" dt="2025-09-26T17:30:34.657" v="576" actId="47"/>
-        <pc:sldMkLst>
-          <pc:docMk/>
-          <pc:sldMk cId="87234602" sldId="257"/>
-        </pc:sldMkLst>
-      </pc:sldChg>
-      <pc:sldChg chg="addSp delSp modSp add del mod setBg">
-        <pc:chgData name="Lorenzo Taddei" userId="30bf616d265f9878" providerId="LiveId" clId="{6FD03176-F394-4DE9-9E07-BC8A4F6F06C0}" dt="2025-09-27T09:32:43.250" v="1524" actId="2696"/>
-        <pc:sldMkLst>
-          <pc:docMk/>
-          <pc:sldMk cId="1414499774" sldId="258"/>
-        </pc:sldMkLst>
-        <pc:spChg chg="mod">
-          <ac:chgData name="Lorenzo Taddei" userId="30bf616d265f9878" providerId="LiveId" clId="{6FD03176-F394-4DE9-9E07-BC8A4F6F06C0}" dt="2025-09-27T08:57:15.680" v="580" actId="1076"/>
-          <ac:spMkLst>
-            <pc:docMk/>
-            <pc:sldMk cId="1414499774" sldId="258"/>
-            <ac:spMk id="2" creationId="{26A6321D-F238-CAD0-6EEA-8850057642C9}"/>
-          </ac:spMkLst>
-        </pc:spChg>
-        <pc:spChg chg="add mod">
-          <ac:chgData name="Lorenzo Taddei" userId="30bf616d265f9878" providerId="LiveId" clId="{6FD03176-F394-4DE9-9E07-BC8A4F6F06C0}" dt="2025-09-27T09:00:21.855" v="673" actId="1076"/>
-          <ac:spMkLst>
-            <pc:docMk/>
-            <pc:sldMk cId="1414499774" sldId="258"/>
-            <ac:spMk id="4" creationId="{598AA9D4-D212-262C-A43F-E2D453E3957F}"/>
-          </ac:spMkLst>
-        </pc:spChg>
-        <pc:spChg chg="add mod">
-          <ac:chgData name="Lorenzo Taddei" userId="30bf616d265f9878" providerId="LiveId" clId="{6FD03176-F394-4DE9-9E07-BC8A4F6F06C0}" dt="2025-09-27T09:13:42.669" v="1184" actId="207"/>
-          <ac:spMkLst>
-            <pc:docMk/>
-            <pc:sldMk cId="1414499774" sldId="258"/>
-            <ac:spMk id="5" creationId="{ABD94CCA-813C-9D63-F000-655479DFDC6E}"/>
-          </ac:spMkLst>
-        </pc:spChg>
-        <pc:spChg chg="add mod">
-          <ac:chgData name="Lorenzo Taddei" userId="30bf616d265f9878" providerId="LiveId" clId="{6FD03176-F394-4DE9-9E07-BC8A4F6F06C0}" dt="2025-09-27T09:10:29.707" v="1072" actId="207"/>
-          <ac:spMkLst>
-            <pc:docMk/>
-            <pc:sldMk cId="1414499774" sldId="258"/>
-            <ac:spMk id="7" creationId="{853D5A12-6CF2-9F1C-8028-EEF8A6AC454A}"/>
-          </ac:spMkLst>
-        </pc:spChg>
-        <pc:spChg chg="add mod">
-          <ac:chgData name="Lorenzo Taddei" userId="30bf616d265f9878" providerId="LiveId" clId="{6FD03176-F394-4DE9-9E07-BC8A4F6F06C0}" dt="2025-09-27T09:16:36.301" v="1321" actId="1076"/>
-          <ac:spMkLst>
-            <pc:docMk/>
-            <pc:sldMk cId="1414499774" sldId="258"/>
-            <ac:spMk id="8" creationId="{F96BA116-154A-2D9E-4516-89620749F2CC}"/>
-          </ac:spMkLst>
-        </pc:spChg>
-        <pc:spChg chg="add mod">
-          <ac:chgData name="Lorenzo Taddei" userId="30bf616d265f9878" providerId="LiveId" clId="{6FD03176-F394-4DE9-9E07-BC8A4F6F06C0}" dt="2025-09-27T09:16:22.474" v="1320" actId="207"/>
-          <ac:spMkLst>
-            <pc:docMk/>
-            <pc:sldMk cId="1414499774" sldId="258"/>
-            <ac:spMk id="9" creationId="{343B04B2-4F2C-4FCC-4489-213EE5FE6EF9}"/>
-          </ac:spMkLst>
-        </pc:spChg>
-      </pc:sldChg>
-      <pc:sldChg chg="new del">
-        <pc:chgData name="Lorenzo Taddei" userId="30bf616d265f9878" providerId="LiveId" clId="{6FD03176-F394-4DE9-9E07-BC8A4F6F06C0}" dt="2025-09-27T09:17:42.789" v="1324" actId="47"/>
-        <pc:sldMkLst>
-          <pc:docMk/>
-          <pc:sldMk cId="405594611" sldId="259"/>
-        </pc:sldMkLst>
-      </pc:sldChg>
-      <pc:sldChg chg="addSp delSp modSp new mod setBg">
-        <pc:chgData name="Lorenzo Taddei" userId="30bf616d265f9878" providerId="LiveId" clId="{6FD03176-F394-4DE9-9E07-BC8A4F6F06C0}" dt="2025-09-27T16:24:05.415" v="1533" actId="20577"/>
-        <pc:sldMkLst>
-          <pc:docMk/>
-          <pc:sldMk cId="3354178094" sldId="259"/>
-        </pc:sldMkLst>
-        <pc:spChg chg="del">
-          <ac:chgData name="Lorenzo Taddei" userId="30bf616d265f9878" providerId="LiveId" clId="{6FD03176-F394-4DE9-9E07-BC8A4F6F06C0}" dt="2025-09-27T09:17:57.299" v="1327" actId="478"/>
-          <ac:spMkLst>
-            <pc:docMk/>
-            <pc:sldMk cId="3354178094" sldId="259"/>
-            <ac:spMk id="2" creationId="{63BDCE68-4EA2-AD72-E89C-BF4AEBCE72A9}"/>
-          </ac:spMkLst>
-        </pc:spChg>
-        <pc:spChg chg="del">
-          <ac:chgData name="Lorenzo Taddei" userId="30bf616d265f9878" providerId="LiveId" clId="{6FD03176-F394-4DE9-9E07-BC8A4F6F06C0}" dt="2025-09-27T09:17:57.299" v="1327" actId="478"/>
-          <ac:spMkLst>
-            <pc:docMk/>
-            <pc:sldMk cId="3354178094" sldId="259"/>
-            <ac:spMk id="3" creationId="{5AAEF32B-B2D2-8E55-9E08-B309B6CF359A}"/>
-          </ac:spMkLst>
-        </pc:spChg>
-        <pc:spChg chg="add mod">
-          <ac:chgData name="Lorenzo Taddei" userId="30bf616d265f9878" providerId="LiveId" clId="{6FD03176-F394-4DE9-9E07-BC8A4F6F06C0}" dt="2025-09-27T09:26:40.639" v="1495" actId="20577"/>
-          <ac:spMkLst>
-            <pc:docMk/>
-            <pc:sldMk cId="3354178094" sldId="259"/>
-            <ac:spMk id="4" creationId="{9F71BADB-DD5C-170C-B3C3-3C3FEB3C806E}"/>
-          </ac:spMkLst>
-        </pc:spChg>
-        <pc:spChg chg="add del mod">
-          <ac:chgData name="Lorenzo Taddei" userId="30bf616d265f9878" providerId="LiveId" clId="{6FD03176-F394-4DE9-9E07-BC8A4F6F06C0}" dt="2025-09-27T09:20:57.252" v="1418" actId="478"/>
-          <ac:spMkLst>
-            <pc:docMk/>
-            <pc:sldMk cId="3354178094" sldId="259"/>
-            <ac:spMk id="5" creationId="{E8738D49-B476-DA1B-3ACA-2249B19B2895}"/>
-          </ac:spMkLst>
-        </pc:spChg>
-        <pc:spChg chg="add mod">
-          <ac:chgData name="Lorenzo Taddei" userId="30bf616d265f9878" providerId="LiveId" clId="{6FD03176-F394-4DE9-9E07-BC8A4F6F06C0}" dt="2025-09-27T16:14:15.418" v="1530" actId="20577"/>
-          <ac:spMkLst>
-            <pc:docMk/>
-            <pc:sldMk cId="3354178094" sldId="259"/>
-            <ac:spMk id="6" creationId="{62B2CDD0-696B-F4C4-9B50-89AF75B19B66}"/>
-          </ac:spMkLst>
-        </pc:spChg>
-        <pc:spChg chg="add mod">
-          <ac:chgData name="Lorenzo Taddei" userId="30bf616d265f9878" providerId="LiveId" clId="{6FD03176-F394-4DE9-9E07-BC8A4F6F06C0}" dt="2025-09-27T16:24:05.415" v="1533" actId="20577"/>
-          <ac:spMkLst>
-            <pc:docMk/>
-            <pc:sldMk cId="3354178094" sldId="259"/>
-            <ac:spMk id="7" creationId="{3AA760C5-1B05-2045-B03C-6EA350881C12}"/>
-          </ac:spMkLst>
-        </pc:spChg>
-        <pc:spChg chg="add mod">
-          <ac:chgData name="Lorenzo Taddei" userId="30bf616d265f9878" providerId="LiveId" clId="{6FD03176-F394-4DE9-9E07-BC8A4F6F06C0}" dt="2025-09-27T09:31:55.199" v="1523" actId="207"/>
-          <ac:spMkLst>
-            <pc:docMk/>
-            <pc:sldMk cId="3354178094" sldId="259"/>
-            <ac:spMk id="8" creationId="{E2D4BA78-5399-F300-D387-6CA0B66B96EB}"/>
-          </ac:spMkLst>
-        </pc:spChg>
-        <pc:spChg chg="add mod">
-          <ac:chgData name="Lorenzo Taddei" userId="30bf616d265f9878" providerId="LiveId" clId="{6FD03176-F394-4DE9-9E07-BC8A4F6F06C0}" dt="2025-09-27T09:30:45.505" v="1517" actId="1076"/>
-          <ac:spMkLst>
-            <pc:docMk/>
-            <pc:sldMk cId="3354178094" sldId="259"/>
-            <ac:spMk id="9" creationId="{3B6C51F0-028F-3DAE-C742-1028F8010DD5}"/>
-          </ac:spMkLst>
-        </pc:spChg>
-      </pc:sldChg>
-      <pc:sldChg chg="modSp add mod">
-        <pc:chgData name="Lorenzo Taddei" userId="30bf616d265f9878" providerId="LiveId" clId="{6FD03176-F394-4DE9-9E07-BC8A4F6F06C0}" dt="2025-09-28T09:25:47.113" v="1566" actId="20577"/>
+      <pc:sldChg chg="addSp modSp add mod">
+        <pc:chgData name="Lorenzo Taddei" userId="30bf616d265f9878" providerId="LiveId" clId="{6FD03176-F394-4DE9-9E07-BC8A4F6F06C0}" dt="2026-03-17T20:38:16.671" v="1589" actId="20577"/>
         <pc:sldMkLst>
           <pc:docMk/>
           <pc:sldMk cId="1867763902" sldId="260"/>
         </pc:sldMkLst>
+        <pc:spChg chg="add mod">
+          <ac:chgData name="Lorenzo Taddei" userId="30bf616d265f9878" providerId="LiveId" clId="{6FD03176-F394-4DE9-9E07-BC8A4F6F06C0}" dt="2026-03-17T16:47:44.252" v="1576" actId="20577"/>
+          <ac:spMkLst>
+            <pc:docMk/>
+            <pc:sldMk cId="1867763902" sldId="260"/>
+            <ac:spMk id="2" creationId="{AA1C7E1B-96AB-11D3-445C-8EA308DD6E81}"/>
+          </ac:spMkLst>
+        </pc:spChg>
         <pc:spChg chg="mod">
-          <ac:chgData name="Lorenzo Taddei" userId="30bf616d265f9878" providerId="LiveId" clId="{6FD03176-F394-4DE9-9E07-BC8A4F6F06C0}" dt="2025-09-28T09:25:47.113" v="1566" actId="20577"/>
+          <ac:chgData name="Lorenzo Taddei" userId="30bf616d265f9878" providerId="LiveId" clId="{6FD03176-F394-4DE9-9E07-BC8A4F6F06C0}" dt="2026-03-17T20:38:16.671" v="1589" actId="20577"/>
           <ac:spMkLst>
             <pc:docMk/>
             <pc:sldMk cId="1867763902" sldId="260"/>
             <ac:spMk id="4" creationId="{4CE36089-89E3-E961-7EB6-3144A9A60B1E}"/>
-          </ac:spMkLst>
-        </pc:spChg>
-        <pc:spChg chg="mod">
-          <ac:chgData name="Lorenzo Taddei" userId="30bf616d265f9878" providerId="LiveId" clId="{6FD03176-F394-4DE9-9E07-BC8A4F6F06C0}" dt="2025-09-27T16:26:24.406" v="1555" actId="20577"/>
-          <ac:spMkLst>
-            <pc:docMk/>
-            <pc:sldMk cId="1867763902" sldId="260"/>
-            <ac:spMk id="7" creationId="{23EC75B3-83C9-FBEE-AA10-F89D59B8B953}"/>
-          </ac:spMkLst>
-        </pc:spChg>
-        <pc:spChg chg="mod">
-          <ac:chgData name="Lorenzo Taddei" userId="30bf616d265f9878" providerId="LiveId" clId="{6FD03176-F394-4DE9-9E07-BC8A4F6F06C0}" dt="2025-09-27T16:26:07.067" v="1553" actId="1076"/>
-          <ac:spMkLst>
-            <pc:docMk/>
-            <pc:sldMk cId="1867763902" sldId="260"/>
-            <ac:spMk id="8" creationId="{BFEB4827-7CA8-1973-B00C-B9388DA7CAE8}"/>
           </ac:spMkLst>
         </pc:spChg>
       </pc:sldChg>
@@ -716,7 +561,7 @@
           <a:p>
             <a:fld id="{39598B85-B088-4DCF-AC6D-F6BFD5953725}" type="datetimeFigureOut">
               <a:rPr lang="en-US" smtClean="0"/>
-              <a:t>9/28/2025</a:t>
+              <a:t>3/17/2026</a:t>
             </a:fld>
             <a:endParaRPr lang="en-US"/>
           </a:p>
@@ -895,7 +740,7 @@
           <a:p>
             <a:fld id="{39598B85-B088-4DCF-AC6D-F6BFD5953725}" type="datetimeFigureOut">
               <a:rPr lang="en-US" smtClean="0"/>
-              <a:t>9/28/2025</a:t>
+              <a:t>3/17/2026</a:t>
             </a:fld>
             <a:endParaRPr lang="en-US"/>
           </a:p>
@@ -1075,7 +920,7 @@
           <a:p>
             <a:fld id="{39598B85-B088-4DCF-AC6D-F6BFD5953725}" type="datetimeFigureOut">
               <a:rPr lang="en-US" smtClean="0"/>
-              <a:t>9/28/2025</a:t>
+              <a:t>3/17/2026</a:t>
             </a:fld>
             <a:endParaRPr lang="en-US"/>
           </a:p>
@@ -1245,7 +1090,7 @@
           <a:p>
             <a:fld id="{39598B85-B088-4DCF-AC6D-F6BFD5953725}" type="datetimeFigureOut">
               <a:rPr lang="en-US" smtClean="0"/>
-              <a:t>9/28/2025</a:t>
+              <a:t>3/17/2026</a:t>
             </a:fld>
             <a:endParaRPr lang="en-US"/>
           </a:p>
@@ -1558,7 +1403,7 @@
           <a:p>
             <a:fld id="{39598B85-B088-4DCF-AC6D-F6BFD5953725}" type="datetimeFigureOut">
               <a:rPr lang="en-US" smtClean="0"/>
-              <a:t>9/28/2025</a:t>
+              <a:t>3/17/2026</a:t>
             </a:fld>
             <a:endParaRPr lang="en-US"/>
           </a:p>
@@ -1944,7 +1789,7 @@
           <a:p>
             <a:fld id="{39598B85-B088-4DCF-AC6D-F6BFD5953725}" type="datetimeFigureOut">
               <a:rPr lang="en-US" smtClean="0"/>
-              <a:t>9/28/2025</a:t>
+              <a:t>3/17/2026</a:t>
             </a:fld>
             <a:endParaRPr lang="en-US"/>
           </a:p>
@@ -2378,7 +2223,7 @@
           <a:p>
             <a:fld id="{39598B85-B088-4DCF-AC6D-F6BFD5953725}" type="datetimeFigureOut">
               <a:rPr lang="en-US" smtClean="0"/>
-              <a:t>9/28/2025</a:t>
+              <a:t>3/17/2026</a:t>
             </a:fld>
             <a:endParaRPr lang="en-US"/>
           </a:p>
@@ -2496,7 +2341,7 @@
           <a:p>
             <a:fld id="{39598B85-B088-4DCF-AC6D-F6BFD5953725}" type="datetimeFigureOut">
               <a:rPr lang="en-US" smtClean="0"/>
-              <a:t>9/28/2025</a:t>
+              <a:t>3/17/2026</a:t>
             </a:fld>
             <a:endParaRPr lang="en-US"/>
           </a:p>
@@ -2591,7 +2436,7 @@
           <a:p>
             <a:fld id="{39598B85-B088-4DCF-AC6D-F6BFD5953725}" type="datetimeFigureOut">
               <a:rPr lang="en-US" smtClean="0"/>
-              <a:t>9/28/2025</a:t>
+              <a:t>3/17/2026</a:t>
             </a:fld>
             <a:endParaRPr lang="en-US"/>
           </a:p>
@@ -2941,7 +2786,7 @@
           <a:p>
             <a:fld id="{39598B85-B088-4DCF-AC6D-F6BFD5953725}" type="datetimeFigureOut">
               <a:rPr lang="en-US" smtClean="0"/>
-              <a:t>9/28/2025</a:t>
+              <a:t>3/17/2026</a:t>
             </a:fld>
             <a:endParaRPr lang="en-US"/>
           </a:p>
@@ -3366,7 +3211,7 @@
           <a:p>
             <a:fld id="{39598B85-B088-4DCF-AC6D-F6BFD5953725}" type="datetimeFigureOut">
               <a:rPr lang="en-US" smtClean="0"/>
-              <a:t>9/28/2025</a:t>
+              <a:t>3/17/2026</a:t>
             </a:fld>
             <a:endParaRPr lang="en-US"/>
           </a:p>
@@ -3647,7 +3492,7 @@
           <a:p>
             <a:fld id="{39598B85-B088-4DCF-AC6D-F6BFD5953725}" type="datetimeFigureOut">
               <a:rPr lang="en-US" smtClean="0"/>
-              <a:t>9/28/2025</a:t>
+              <a:t>3/17/2026</a:t>
             </a:fld>
             <a:endParaRPr lang="en-US"/>
           </a:p>
@@ -4888,7 +4733,7 @@
                 </a:solidFill>
                 <a:latin typeface="Bahnschrift SemiLight" panose="020B0502040204020203" pitchFamily="34" charset="0"/>
               </a:rPr>
-              <a:t>Ceramics</a:t>
+              <a:t>Woodworking</a:t>
             </a:r>
             <a:endParaRPr kumimoji="0" lang="en-US" sz="2400" b="0" i="0" u="none" strike="noStrike" kern="1200" cap="none" spc="0" normalizeH="0" baseline="0" noProof="0" dirty="0">
               <a:ln>
@@ -5314,6 +5159,112 @@
               <a:ea typeface="+mn-ea"/>
               <a:cs typeface="+mn-cs"/>
             </a:endParaRPr>
+          </a:p>
+        </p:txBody>
+      </p:sp>
+      <p:sp>
+        <p:nvSpPr>
+          <p:cNvPr id="2" name="Rectangle: Rounded Corners 1">
+            <a:extLst>
+              <a:ext uri="{FF2B5EF4-FFF2-40B4-BE49-F238E27FC236}">
+                <a16:creationId xmlns:a16="http://schemas.microsoft.com/office/drawing/2014/main" id="{AA1C7E1B-96AB-11D3-445C-8EA308DD6E81}"/>
+              </a:ext>
+            </a:extLst>
+          </p:cNvPr>
+          <p:cNvSpPr/>
+          <p:nvPr/>
+        </p:nvSpPr>
+        <p:spPr>
+          <a:xfrm>
+            <a:off x="5679440" y="3055620"/>
+            <a:ext cx="3779520" cy="711200"/>
+          </a:xfrm>
+          <a:prstGeom prst="roundRect">
+            <a:avLst/>
+          </a:prstGeom>
+          <a:gradFill flip="none" rotWithShape="1">
+            <a:gsLst>
+              <a:gs pos="0">
+                <a:schemeClr val="accent3">
+                  <a:lumMod val="67000"/>
+                </a:schemeClr>
+              </a:gs>
+              <a:gs pos="48000">
+                <a:schemeClr val="accent3">
+                  <a:lumMod val="97000"/>
+                  <a:lumOff val="3000"/>
+                </a:schemeClr>
+              </a:gs>
+              <a:gs pos="100000">
+                <a:schemeClr val="accent3">
+                  <a:lumMod val="60000"/>
+                  <a:lumOff val="40000"/>
+                </a:schemeClr>
+              </a:gs>
+            </a:gsLst>
+            <a:lin ang="16200000" scaled="1"/>
+            <a:tileRect/>
+          </a:gradFill>
+          <a:ln w="19050">
+            <a:solidFill>
+              <a:schemeClr val="tx2"/>
+            </a:solidFill>
+          </a:ln>
+        </p:spPr>
+        <p:style>
+          <a:lnRef idx="0">
+            <a:scrgbClr r="0" g="0" b="0"/>
+          </a:lnRef>
+          <a:fillRef idx="0">
+            <a:scrgbClr r="0" g="0" b="0"/>
+          </a:fillRef>
+          <a:effectRef idx="0">
+            <a:scrgbClr r="0" g="0" b="0"/>
+          </a:effectRef>
+          <a:fontRef idx="minor">
+            <a:schemeClr val="lt1"/>
+          </a:fontRef>
+        </p:style>
+        <p:txBody>
+          <a:bodyPr rtlCol="0" anchor="ctr"/>
+          <a:lstStyle/>
+          <a:p>
+            <a:pPr marL="0" marR="0" lvl="0" indent="0" algn="ctr" defTabSz="457200" rtl="0" eaLnBrk="1" fontAlgn="auto" latinLnBrk="0" hangingPunct="1">
+              <a:lnSpc>
+                <a:spcPct val="100000"/>
+              </a:lnSpc>
+              <a:spcBef>
+                <a:spcPts val="0"/>
+              </a:spcBef>
+              <a:spcAft>
+                <a:spcPts val="0"/>
+              </a:spcAft>
+              <a:buClrTx/>
+              <a:buSzTx/>
+              <a:buFontTx/>
+              <a:buNone/>
+              <a:tabLst/>
+              <a:defRPr/>
+            </a:pPr>
+            <a:r>
+              <a:rPr kumimoji="0" lang="en-US" sz="2400" b="0" i="0" u="none" strike="noStrike" kern="1200" cap="none" spc="0" normalizeH="0" baseline="0" noProof="0" dirty="0">
+                <a:ln>
+                  <a:noFill/>
+                </a:ln>
+                <a:solidFill>
+                  <a:srgbClr val="545454">
+                    <a:lumMod val="75000"/>
+                  </a:srgbClr>
+                </a:solidFill>
+                <a:effectLst/>
+                <a:uLnTx/>
+                <a:uFillTx/>
+                <a:latin typeface="Bahnschrift SemiLight" panose="020B0502040204020203" pitchFamily="34" charset="0"/>
+                <a:ea typeface="+mn-ea"/>
+                <a:cs typeface="+mn-cs"/>
+              </a:rPr>
+              <a:t>Ceramics</a:t>
+            </a:r>
           </a:p>
         </p:txBody>
       </p:sp>

</xml_diff>